<commit_message>
deck: product-visual slide (live grid screenshot) added
</commit_message>
<xml_diff>
--- a/data/delphi_technical.pptx
+++ b/data/delphi_technical.pptx
@@ -12,6 +12,7 @@
     <p:sldId id="260" r:id="rId11"/>
     <p:sldId id="261" r:id="rId12"/>
     <p:sldId id="262" r:id="rId13"/>
+    <p:sldId id="263" r:id="rId14"/>
   </p:sldIdLst>
   <p:sldSz cx="12191695" cy="6858000" type="screen4x3"/>
   <p:notesSz cx="6858000" cy="9144000"/>
@@ -111,6 +112,426 @@
     </a:lvl9pPr>
   </p:defaultTextStyle>
 </p:presentation>
+</file>
+
+<file path=ppt/notesMasters/notesMaster1.xml><?xml version="1.0" encoding="utf-8"?>
+<p:notesMaster xmlns:a="http://schemas.openxmlformats.org/drawingml/2006/main" xmlns:p="http://schemas.openxmlformats.org/presentationml/2006/main" xmlns:r="http://schemas.openxmlformats.org/officeDocument/2006/relationships">
+  <p:cSld>
+    <p:bg>
+      <p:bgRef idx="1001">
+        <a:schemeClr val="bg1"/>
+      </p:bgRef>
+    </p:bg>
+    <p:spTree>
+      <p:nvGrpSpPr>
+        <p:cNvPr id="1" name=""/>
+        <p:cNvGrpSpPr/>
+        <p:nvPr/>
+      </p:nvGrpSpPr>
+      <p:grpSpPr>
+        <a:xfrm>
+          <a:off x="0" y="0"/>
+          <a:ext cx="0" cy="0"/>
+          <a:chOff x="0" y="0"/>
+          <a:chExt cx="0" cy="0"/>
+        </a:xfrm>
+      </p:grpSpPr>
+      <p:sp>
+        <p:nvSpPr>
+          <p:cNvPr id="2" name="Header Placeholder 1"/>
+          <p:cNvSpPr>
+            <a:spLocks noGrp="1"/>
+          </p:cNvSpPr>
+          <p:nvPr>
+            <p:ph type="hdr" sz="quarter"/>
+          </p:nvPr>
+        </p:nvSpPr>
+        <p:spPr>
+          <a:xfrm>
+            <a:off x="0" y="0"/>
+            <a:ext cx="2971800" cy="457200"/>
+          </a:xfrm>
+          <a:prstGeom prst="rect">
+            <a:avLst/>
+          </a:prstGeom>
+        </p:spPr>
+        <p:txBody>
+          <a:bodyPr vert="horz" lIns="91440" tIns="45720" rIns="91440" bIns="45720" rtlCol="0"/>
+          <a:lstStyle>
+            <a:lvl1pPr algn="l">
+              <a:defRPr sz="1200"/>
+            </a:lvl1pPr>
+          </a:lstStyle>
+          <a:p>
+            <a:endParaRPr lang="en-US"/>
+          </a:p>
+        </p:txBody>
+      </p:sp>
+      <p:sp>
+        <p:nvSpPr>
+          <p:cNvPr id="3" name="Date Placeholder 2"/>
+          <p:cNvSpPr>
+            <a:spLocks noGrp="1"/>
+          </p:cNvSpPr>
+          <p:nvPr>
+            <p:ph type="dt" idx="1"/>
+          </p:nvPr>
+        </p:nvSpPr>
+        <p:spPr>
+          <a:xfrm>
+            <a:off x="3884613" y="0"/>
+            <a:ext cx="2971800" cy="457200"/>
+          </a:xfrm>
+          <a:prstGeom prst="rect">
+            <a:avLst/>
+          </a:prstGeom>
+        </p:spPr>
+        <p:txBody>
+          <a:bodyPr vert="horz" lIns="91440" tIns="45720" rIns="91440" bIns="45720" rtlCol="0"/>
+          <a:lstStyle>
+            <a:lvl1pPr algn="r">
+              <a:defRPr sz="1200"/>
+            </a:lvl1pPr>
+          </a:lstStyle>
+          <a:p>
+            <a:fld id="{0F89C1C7-3DCD-1040-A9CF-14679D8B5DDD}" type="datetimeFigureOut">
+              <a:rPr lang="en-US" smtClean="0"/>
+              <a:t>10/17/16</a:t>
+            </a:fld>
+            <a:endParaRPr lang="en-US"/>
+          </a:p>
+        </p:txBody>
+      </p:sp>
+      <p:sp>
+        <p:nvSpPr>
+          <p:cNvPr id="4" name="Slide Image Placeholder 3"/>
+          <p:cNvSpPr>
+            <a:spLocks noGrp="1" noRot="1" noChangeAspect="1"/>
+          </p:cNvSpPr>
+          <p:nvPr>
+            <p:ph type="sldImg" idx="2"/>
+          </p:nvPr>
+        </p:nvSpPr>
+        <p:spPr>
+          <a:xfrm>
+            <a:off x="1143000" y="685800"/>
+            <a:ext cx="4572000" cy="3429000"/>
+          </a:xfrm>
+          <a:prstGeom prst="rect">
+            <a:avLst/>
+          </a:prstGeom>
+          <a:noFill/>
+          <a:ln w="12700">
+            <a:solidFill>
+              <a:prstClr val="black"/>
+            </a:solidFill>
+          </a:ln>
+        </p:spPr>
+        <p:txBody>
+          <a:bodyPr vert="horz" lIns="91440" tIns="45720" rIns="91440" bIns="45720" rtlCol="0" anchor="ctr"/>
+          <a:lstStyle/>
+          <a:p>
+            <a:endParaRPr lang="en-US"/>
+          </a:p>
+        </p:txBody>
+      </p:sp>
+      <p:sp>
+        <p:nvSpPr>
+          <p:cNvPr id="5" name="Notes Placeholder 4"/>
+          <p:cNvSpPr>
+            <a:spLocks noGrp="1"/>
+          </p:cNvSpPr>
+          <p:nvPr>
+            <p:ph type="body" sz="quarter" idx="3"/>
+          </p:nvPr>
+        </p:nvSpPr>
+        <p:spPr>
+          <a:xfrm>
+            <a:off x="685800" y="4343400"/>
+            <a:ext cx="5486400" cy="4114800"/>
+          </a:xfrm>
+          <a:prstGeom prst="rect">
+            <a:avLst/>
+          </a:prstGeom>
+        </p:spPr>
+        <p:txBody>
+          <a:bodyPr vert="horz" lIns="91440" tIns="45720" rIns="91440" bIns="45720" rtlCol="0"/>
+          <a:lstStyle/>
+          <a:p>
+            <a:pPr lvl="0"/>
+            <a:r>
+              <a:rPr lang="en-US" smtClean="0"/>
+              <a:t>Click to edit Master text styles</a:t>
+            </a:r>
+          </a:p>
+          <a:p>
+            <a:pPr lvl="1"/>
+            <a:r>
+              <a:rPr lang="en-US" smtClean="0"/>
+              <a:t>Second level</a:t>
+            </a:r>
+          </a:p>
+          <a:p>
+            <a:pPr lvl="2"/>
+            <a:r>
+              <a:rPr lang="en-US" smtClean="0"/>
+              <a:t>Third level</a:t>
+            </a:r>
+          </a:p>
+          <a:p>
+            <a:pPr lvl="3"/>
+            <a:r>
+              <a:rPr lang="en-US" smtClean="0"/>
+              <a:t>Fourth level</a:t>
+            </a:r>
+          </a:p>
+          <a:p>
+            <a:pPr lvl="4"/>
+            <a:r>
+              <a:rPr lang="en-US" smtClean="0"/>
+              <a:t>Fifth level</a:t>
+            </a:r>
+            <a:endParaRPr lang="en-US"/>
+          </a:p>
+        </p:txBody>
+      </p:sp>
+      <p:sp>
+        <p:nvSpPr>
+          <p:cNvPr id="6" name="Footer Placeholder 5"/>
+          <p:cNvSpPr>
+            <a:spLocks noGrp="1"/>
+          </p:cNvSpPr>
+          <p:nvPr>
+            <p:ph type="ftr" sz="quarter" idx="4"/>
+          </p:nvPr>
+        </p:nvSpPr>
+        <p:spPr>
+          <a:xfrm>
+            <a:off x="0" y="8685213"/>
+            <a:ext cx="2971800" cy="457200"/>
+          </a:xfrm>
+          <a:prstGeom prst="rect">
+            <a:avLst/>
+          </a:prstGeom>
+        </p:spPr>
+        <p:txBody>
+          <a:bodyPr vert="horz" lIns="91440" tIns="45720" rIns="91440" bIns="45720" rtlCol="0" anchor="b"/>
+          <a:lstStyle>
+            <a:lvl1pPr algn="l">
+              <a:defRPr sz="1200"/>
+            </a:lvl1pPr>
+          </a:lstStyle>
+          <a:p>
+            <a:endParaRPr lang="en-US"/>
+          </a:p>
+        </p:txBody>
+      </p:sp>
+      <p:sp>
+        <p:nvSpPr>
+          <p:cNvPr id="7" name="Slide Number Placeholder 6"/>
+          <p:cNvSpPr>
+            <a:spLocks noGrp="1"/>
+          </p:cNvSpPr>
+          <p:nvPr>
+            <p:ph type="sldNum" sz="quarter" idx="5"/>
+          </p:nvPr>
+        </p:nvSpPr>
+        <p:spPr>
+          <a:xfrm>
+            <a:off x="3884613" y="8685213"/>
+            <a:ext cx="2971800" cy="457200"/>
+          </a:xfrm>
+          <a:prstGeom prst="rect">
+            <a:avLst/>
+          </a:prstGeom>
+        </p:spPr>
+        <p:txBody>
+          <a:bodyPr vert="horz" lIns="91440" tIns="45720" rIns="91440" bIns="45720" rtlCol="0" anchor="b"/>
+          <a:lstStyle>
+            <a:lvl1pPr algn="r">
+              <a:defRPr sz="1200"/>
+            </a:lvl1pPr>
+          </a:lstStyle>
+          <a:p>
+            <a:fld id="{BB5E49A5-4136-284D-997B-48E1D791AD67}" type="slidenum">
+              <a:rPr lang="en-US" smtClean="0"/>
+              <a:t>‹#›</a:t>
+            </a:fld>
+            <a:endParaRPr lang="en-US"/>
+          </a:p>
+        </p:txBody>
+      </p:sp>
+    </p:spTree>
+    <p:extLst>
+      <p:ext uri="{BB962C8B-B14F-4D97-AF65-F5344CB8AC3E}">
+        <p14:creationId xmlns:p14="http://schemas.microsoft.com/office/powerpoint/2010/main" val="2623252185"/>
+      </p:ext>
+    </p:extLst>
+  </p:cSld>
+  <p:clrMap bg1="lt1" tx1="dk1" bg2="lt2" tx2="dk2" accent1="accent1" accent2="accent2" accent3="accent3" accent4="accent4" accent5="accent5" accent6="accent6" hlink="hlink" folHlink="folHlink"/>
+  <p:notesStyle>
+    <a:lvl1pPr marL="0" algn="l" defTabSz="457200" rtl="0" eaLnBrk="1" latinLnBrk="0" hangingPunct="1">
+      <a:defRPr sz="1200" kern="1200">
+        <a:solidFill>
+          <a:schemeClr val="tx1"/>
+        </a:solidFill>
+        <a:latin typeface="+mn-lt"/>
+        <a:ea typeface="+mn-ea"/>
+        <a:cs typeface="+mn-cs"/>
+      </a:defRPr>
+    </a:lvl1pPr>
+    <a:lvl2pPr marL="457200" algn="l" defTabSz="457200" rtl="0" eaLnBrk="1" latinLnBrk="0" hangingPunct="1">
+      <a:defRPr sz="1200" kern="1200">
+        <a:solidFill>
+          <a:schemeClr val="tx1"/>
+        </a:solidFill>
+        <a:latin typeface="+mn-lt"/>
+        <a:ea typeface="+mn-ea"/>
+        <a:cs typeface="+mn-cs"/>
+      </a:defRPr>
+    </a:lvl2pPr>
+    <a:lvl3pPr marL="914400" algn="l" defTabSz="457200" rtl="0" eaLnBrk="1" latinLnBrk="0" hangingPunct="1">
+      <a:defRPr sz="1200" kern="1200">
+        <a:solidFill>
+          <a:schemeClr val="tx1"/>
+        </a:solidFill>
+        <a:latin typeface="+mn-lt"/>
+        <a:ea typeface="+mn-ea"/>
+        <a:cs typeface="+mn-cs"/>
+      </a:defRPr>
+    </a:lvl3pPr>
+    <a:lvl4pPr marL="1371600" algn="l" defTabSz="457200" rtl="0" eaLnBrk="1" latinLnBrk="0" hangingPunct="1">
+      <a:defRPr sz="1200" kern="1200">
+        <a:solidFill>
+          <a:schemeClr val="tx1"/>
+        </a:solidFill>
+        <a:latin typeface="+mn-lt"/>
+        <a:ea typeface="+mn-ea"/>
+        <a:cs typeface="+mn-cs"/>
+      </a:defRPr>
+    </a:lvl4pPr>
+    <a:lvl5pPr marL="1828800" algn="l" defTabSz="457200" rtl="0" eaLnBrk="1" latinLnBrk="0" hangingPunct="1">
+      <a:defRPr sz="1200" kern="1200">
+        <a:solidFill>
+          <a:schemeClr val="tx1"/>
+        </a:solidFill>
+        <a:latin typeface="+mn-lt"/>
+        <a:ea typeface="+mn-ea"/>
+        <a:cs typeface="+mn-cs"/>
+      </a:defRPr>
+    </a:lvl5pPr>
+    <a:lvl6pPr marL="2286000" algn="l" defTabSz="457200" rtl="0" eaLnBrk="1" latinLnBrk="0" hangingPunct="1">
+      <a:defRPr sz="1200" kern="1200">
+        <a:solidFill>
+          <a:schemeClr val="tx1"/>
+        </a:solidFill>
+        <a:latin typeface="+mn-lt"/>
+        <a:ea typeface="+mn-ea"/>
+        <a:cs typeface="+mn-cs"/>
+      </a:defRPr>
+    </a:lvl6pPr>
+    <a:lvl7pPr marL="2743200" algn="l" defTabSz="457200" rtl="0" eaLnBrk="1" latinLnBrk="0" hangingPunct="1">
+      <a:defRPr sz="1200" kern="1200">
+        <a:solidFill>
+          <a:schemeClr val="tx1"/>
+        </a:solidFill>
+        <a:latin typeface="+mn-lt"/>
+        <a:ea typeface="+mn-ea"/>
+        <a:cs typeface="+mn-cs"/>
+      </a:defRPr>
+    </a:lvl7pPr>
+    <a:lvl8pPr marL="3200400" algn="l" defTabSz="457200" rtl="0" eaLnBrk="1" latinLnBrk="0" hangingPunct="1">
+      <a:defRPr sz="1200" kern="1200">
+        <a:solidFill>
+          <a:schemeClr val="tx1"/>
+        </a:solidFill>
+        <a:latin typeface="+mn-lt"/>
+        <a:ea typeface="+mn-ea"/>
+        <a:cs typeface="+mn-cs"/>
+      </a:defRPr>
+    </a:lvl8pPr>
+    <a:lvl9pPr marL="3657600" algn="l" defTabSz="457200" rtl="0" eaLnBrk="1" latinLnBrk="0" hangingPunct="1">
+      <a:defRPr sz="1200" kern="1200">
+        <a:solidFill>
+          <a:schemeClr val="tx1"/>
+        </a:solidFill>
+        <a:latin typeface="+mn-lt"/>
+        <a:ea typeface="+mn-ea"/>
+        <a:cs typeface="+mn-cs"/>
+      </a:defRPr>
+    </a:lvl9pPr>
+  </p:notesStyle>
+</p:notesMaster>
+</file>
+
+<file path=ppt/notesSlides/notesSlide1.xml><?xml version="1.0" encoding="utf-8"?>
+<p:notes xmlns:a="http://schemas.openxmlformats.org/drawingml/2006/main" xmlns:p="http://schemas.openxmlformats.org/presentationml/2006/main" xmlns:r="http://schemas.openxmlformats.org/officeDocument/2006/relationships">
+  <p:cSld>
+    <p:spTree>
+      <p:nvGrpSpPr>
+        <p:cNvPr id="1" name=""/>
+        <p:cNvGrpSpPr/>
+        <p:nvPr/>
+      </p:nvGrpSpPr>
+      <p:grpSpPr>
+        <a:xfrm>
+          <a:off x="0" y="0"/>
+          <a:ext cx="0" cy="0"/>
+          <a:chOff x="0" y="0"/>
+          <a:chExt cx="0" cy="0"/>
+        </a:xfrm>
+      </p:grpSpPr>
+      <p:sp>
+        <p:nvSpPr>
+          <p:cNvPr id="2" name="Slide Image Placeholder 1"/>
+          <p:cNvSpPr>
+            <a:spLocks noGrp="1"/>
+          </p:cNvSpPr>
+          <p:nvPr>
+            <p:ph type="sldImg" idx="2"/>
+          </p:nvPr>
+        </p:nvSpPr>
+        <p:spPr/>
+      </p:sp>
+      <p:sp>
+        <p:nvSpPr>
+          <p:cNvPr id="3" name="Notes Placeholder 2"/>
+          <p:cNvSpPr>
+            <a:spLocks noGrp="1"/>
+          </p:cNvSpPr>
+          <p:nvPr>
+            <p:ph type="body" idx="3" sz="quarter"/>
+          </p:nvPr>
+        </p:nvSpPr>
+        <p:spPr/>
+        <p:txBody>
+          <a:bodyPr/>
+          <a:lstStyle/>
+          <a:p>
+            <a:r>
+              <a:t>Live grid (seerscore.pages.dev): five tracked columns; verdict boxes (Panel Judgement / MARTY'S VERDICT FINAL); Delphi3080 badges with hover rationale tooltips.</a:t>
+            </a:r>
+          </a:p>
+        </p:txBody>
+      </p:sp>
+      <p:sp>
+        <p:nvSpPr>
+          <p:cNvPr id="4" name="Slide Number Placeholder 3"/>
+          <p:cNvSpPr>
+            <a:spLocks noGrp="1"/>
+          </p:cNvSpPr>
+          <p:nvPr>
+            <p:ph type="sldNum" idx="5" sz="quarter"/>
+          </p:nvPr>
+        </p:nvSpPr>
+        <p:spPr/>
+      </p:sp>
+    </p:spTree>
+  </p:cSld>
+  <p:clrMapOvr>
+    <a:masterClrMapping/>
+  </p:clrMapOvr>
+</p:notes>
 </file>
 
 <file path=ppt/slideLayouts/slideLayout1.xml><?xml version="1.0" encoding="utf-8"?>
@@ -3739,6 +4160,77 @@
           </a:p>
         </p:txBody>
       </p:sp>
+    </p:spTree>
+  </p:cSld>
+  <p:clrMapOvr>
+    <a:masterClrMapping/>
+  </p:clrMapOvr>
+</p:sld>
+</file>
+
+<file path=ppt/slides/slide8.xml><?xml version="1.0" encoding="utf-8"?>
+<p:sld xmlns:a="http://schemas.openxmlformats.org/drawingml/2006/main" xmlns:p="http://schemas.openxmlformats.org/presentationml/2006/main" xmlns:r="http://schemas.openxmlformats.org/officeDocument/2006/relationships">
+  <p:cSld>
+    <p:bg>
+      <p:bgPr>
+        <a:solidFill>
+          <a:srgbClr val="0B1120"/>
+        </a:solidFill>
+        <a:effectLst/>
+      </p:bgPr>
+    </p:bg>
+    <p:spTree>
+      <p:nvGrpSpPr>
+        <p:cNvPr id="1" name=""/>
+        <p:cNvGrpSpPr/>
+        <p:nvPr/>
+      </p:nvGrpSpPr>
+      <p:grpSpPr/>
+      <p:sp>
+        <p:nvSpPr>
+          <p:cNvPr id="2" name="Title 1"/>
+          <p:cNvSpPr>
+            <a:spLocks noGrp="1"/>
+          </p:cNvSpPr>
+          <p:nvPr>
+            <p:ph type="title"/>
+          </p:nvPr>
+        </p:nvSpPr>
+        <p:spPr/>
+        <p:txBody>
+          <a:bodyPr/>
+          <a:lstStyle/>
+          <a:p>
+            <a:r>
+              <a:t>7 · The product this adjudication feeds</a:t>
+            </a:r>
+          </a:p>
+        </p:txBody>
+      </p:sp>
+      <p:pic>
+        <p:nvPicPr>
+          <p:cNvPr id="3" name="Picture 2" descr="grid_shot.png"/>
+          <p:cNvPicPr>
+            <a:picLocks noChangeAspect="1"/>
+          </p:cNvPicPr>
+          <p:nvPr/>
+        </p:nvPicPr>
+        <p:blipFill>
+          <a:blip r:embed="rId2"/>
+          <a:stretch>
+            <a:fillRect/>
+          </a:stretch>
+        </p:blipFill>
+        <p:spPr>
+          <a:xfrm>
+            <a:off x="457200" y="1371600"/>
+            <a:ext cx="11430000" cy="6429375"/>
+          </a:xfrm>
+          <a:prstGeom prst="rect">
+            <a:avLst/>
+          </a:prstGeom>
+        </p:spPr>
+      </p:pic>
     </p:spTree>
   </p:cSld>
   <p:clrMapOvr>
@@ -4065,4 +4557,324 @@
   </a:objectDefaults>
   <a:extraClrSchemeLst/>
 </a:theme>
+</file>
+
+<file path=ppt/theme/theme2.xml><?xml version="1.0" encoding="utf-8"?>
+<a:theme xmlns:a="http://schemas.openxmlformats.org/drawingml/2006/main" name="Office Theme">
+  <a:themeElements>
+    <a:clrScheme name="Office">
+      <a:dk1>
+        <a:sysClr val="windowText" lastClr="000000"/>
+      </a:dk1>
+      <a:lt1>
+        <a:sysClr val="window" lastClr="FFFFFF"/>
+      </a:lt1>
+      <a:dk2>
+        <a:srgbClr val="1F497D"/>
+      </a:dk2>
+      <a:lt2>
+        <a:srgbClr val="EEECE1"/>
+      </a:lt2>
+      <a:accent1>
+        <a:srgbClr val="4F81BD"/>
+      </a:accent1>
+      <a:accent2>
+        <a:srgbClr val="C0504D"/>
+      </a:accent2>
+      <a:accent3>
+        <a:srgbClr val="9BBB59"/>
+      </a:accent3>
+      <a:accent4>
+        <a:srgbClr val="8064A2"/>
+      </a:accent4>
+      <a:accent5>
+        <a:srgbClr val="4BACC6"/>
+      </a:accent5>
+      <a:accent6>
+        <a:srgbClr val="F79646"/>
+      </a:accent6>
+      <a:hlink>
+        <a:srgbClr val="0000FF"/>
+      </a:hlink>
+      <a:folHlink>
+        <a:srgbClr val="800080"/>
+      </a:folHlink>
+    </a:clrScheme>
+    <a:fontScheme name="Office">
+      <a:majorFont>
+        <a:latin typeface="Calibri"/>
+        <a:ea typeface=""/>
+        <a:cs typeface=""/>
+        <a:font script="Jpan" typeface="ＭＳ Ｐゴシック"/>
+        <a:font script="Hang" typeface="맑은 고딕"/>
+        <a:font script="Hans" typeface="宋体"/>
+        <a:font script="Hant" typeface="新細明體"/>
+        <a:font script="Arab" typeface="Times New Roman"/>
+        <a:font script="Hebr" typeface="Times New Roman"/>
+        <a:font script="Thai" typeface="Angsana New"/>
+        <a:font script="Ethi" typeface="Nyala"/>
+        <a:font script="Beng" typeface="Vrinda"/>
+        <a:font script="Gujr" typeface="Shruti"/>
+        <a:font script="Khmr" typeface="MoolBoran"/>
+        <a:font script="Knda" typeface="Tunga"/>
+        <a:font script="Guru" typeface="Raavi"/>
+        <a:font script="Cans" typeface="Euphemia"/>
+        <a:font script="Cher" typeface="Plantagenet Cherokee"/>
+        <a:font script="Yiii" typeface="Microsoft Yi Baiti"/>
+        <a:font script="Tibt" typeface="Microsoft Himalaya"/>
+        <a:font script="Thaa" typeface="MV Boli"/>
+        <a:font script="Deva" typeface="Mangal"/>
+        <a:font script="Telu" typeface="Gautami"/>
+        <a:font script="Taml" typeface="Latha"/>
+        <a:font script="Syrc" typeface="Estrangelo Edessa"/>
+        <a:font script="Orya" typeface="Kalinga"/>
+        <a:font script="Mlym" typeface="Kartika"/>
+        <a:font script="Laoo" typeface="DokChampa"/>
+        <a:font script="Sinh" typeface="Iskoola Pota"/>
+        <a:font script="Mong" typeface="Mongolian Baiti"/>
+        <a:font script="Viet" typeface="Times New Roman"/>
+        <a:font script="Uigh" typeface="Microsoft Uighur"/>
+        <a:font script="Geor" typeface="Sylfaen"/>
+      </a:majorFont>
+      <a:minorFont>
+        <a:latin typeface="Calibri"/>
+        <a:ea typeface=""/>
+        <a:cs typeface=""/>
+        <a:font script="Jpan" typeface="ＭＳ Ｐゴシック"/>
+        <a:font script="Hang" typeface="맑은 고딕"/>
+        <a:font script="Hans" typeface="宋体"/>
+        <a:font script="Hant" typeface="新細明體"/>
+        <a:font script="Arab" typeface="Arial"/>
+        <a:font script="Hebr" typeface="Arial"/>
+        <a:font script="Thai" typeface="Cordia New"/>
+        <a:font script="Ethi" typeface="Nyala"/>
+        <a:font script="Beng" typeface="Vrinda"/>
+        <a:font script="Gujr" typeface="Shruti"/>
+        <a:font script="Khmr" typeface="DaunPenh"/>
+        <a:font script="Knda" typeface="Tunga"/>
+        <a:font script="Guru" typeface="Raavi"/>
+        <a:font script="Cans" typeface="Euphemia"/>
+        <a:font script="Cher" typeface="Plantagenet Cherokee"/>
+        <a:font script="Yiii" typeface="Microsoft Yi Baiti"/>
+        <a:font script="Tibt" typeface="Microsoft Himalaya"/>
+        <a:font script="Thaa" typeface="MV Boli"/>
+        <a:font script="Deva" typeface="Mangal"/>
+        <a:font script="Telu" typeface="Gautami"/>
+        <a:font script="Taml" typeface="Latha"/>
+        <a:font script="Syrc" typeface="Estrangelo Edessa"/>
+        <a:font script="Orya" typeface="Kalinga"/>
+        <a:font script="Mlym" typeface="Kartika"/>
+        <a:font script="Laoo" typeface="DokChampa"/>
+        <a:font script="Sinh" typeface="Iskoola Pota"/>
+        <a:font script="Mong" typeface="Mongolian Baiti"/>
+        <a:font script="Viet" typeface="Arial"/>
+        <a:font script="Uigh" typeface="Microsoft Uighur"/>
+        <a:font script="Geor" typeface="Sylfaen"/>
+      </a:minorFont>
+    </a:fontScheme>
+    <a:fmtScheme name="Office">
+      <a:fillStyleLst>
+        <a:solidFill>
+          <a:schemeClr val="phClr"/>
+        </a:solidFill>
+        <a:gradFill rotWithShape="1">
+          <a:gsLst>
+            <a:gs pos="0">
+              <a:schemeClr val="phClr">
+                <a:tint val="50000"/>
+                <a:satMod val="300000"/>
+              </a:schemeClr>
+            </a:gs>
+            <a:gs pos="35000">
+              <a:schemeClr val="phClr">
+                <a:tint val="37000"/>
+                <a:satMod val="300000"/>
+              </a:schemeClr>
+            </a:gs>
+            <a:gs pos="100000">
+              <a:schemeClr val="phClr">
+                <a:tint val="15000"/>
+                <a:satMod val="350000"/>
+              </a:schemeClr>
+            </a:gs>
+          </a:gsLst>
+          <a:lin ang="16200000" scaled="1"/>
+        </a:gradFill>
+        <a:gradFill rotWithShape="1">
+          <a:gsLst>
+            <a:gs pos="0">
+              <a:schemeClr val="phClr">
+                <a:tint val="100000"/>
+                <a:shade val="100000"/>
+                <a:satMod val="130000"/>
+              </a:schemeClr>
+            </a:gs>
+            <a:gs pos="100000">
+              <a:schemeClr val="phClr">
+                <a:tint val="50000"/>
+                <a:shade val="100000"/>
+                <a:satMod val="350000"/>
+              </a:schemeClr>
+            </a:gs>
+          </a:gsLst>
+          <a:lin ang="16200000" scaled="0"/>
+        </a:gradFill>
+      </a:fillStyleLst>
+      <a:lnStyleLst>
+        <a:ln w="9525" cap="flat" cmpd="sng" algn="ctr">
+          <a:solidFill>
+            <a:schemeClr val="phClr">
+              <a:shade val="95000"/>
+              <a:satMod val="105000"/>
+            </a:schemeClr>
+          </a:solidFill>
+          <a:prstDash val="solid"/>
+        </a:ln>
+        <a:ln w="25400" cap="flat" cmpd="sng" algn="ctr">
+          <a:solidFill>
+            <a:schemeClr val="phClr"/>
+          </a:solidFill>
+          <a:prstDash val="solid"/>
+        </a:ln>
+        <a:ln w="38100" cap="flat" cmpd="sng" algn="ctr">
+          <a:solidFill>
+            <a:schemeClr val="phClr"/>
+          </a:solidFill>
+          <a:prstDash val="solid"/>
+        </a:ln>
+      </a:lnStyleLst>
+      <a:effectStyleLst>
+        <a:effectStyle>
+          <a:effectLst>
+            <a:outerShdw blurRad="40000" dist="20000" dir="5400000" rotWithShape="0">
+              <a:srgbClr val="000000">
+                <a:alpha val="38000"/>
+              </a:srgbClr>
+            </a:outerShdw>
+          </a:effectLst>
+        </a:effectStyle>
+        <a:effectStyle>
+          <a:effectLst>
+            <a:outerShdw blurRad="40000" dist="23000" dir="5400000" rotWithShape="0">
+              <a:srgbClr val="000000">
+                <a:alpha val="35000"/>
+              </a:srgbClr>
+            </a:outerShdw>
+          </a:effectLst>
+        </a:effectStyle>
+        <a:effectStyle>
+          <a:effectLst>
+            <a:outerShdw blurRad="40000" dist="23000" dir="5400000" rotWithShape="0">
+              <a:srgbClr val="000000">
+                <a:alpha val="35000"/>
+              </a:srgbClr>
+            </a:outerShdw>
+          </a:effectLst>
+          <a:scene3d>
+            <a:camera prst="orthographicFront">
+              <a:rot lat="0" lon="0" rev="0"/>
+            </a:camera>
+            <a:lightRig rig="threePt" dir="t">
+              <a:rot lat="0" lon="0" rev="1200000"/>
+            </a:lightRig>
+          </a:scene3d>
+          <a:sp3d>
+            <a:bevelT w="63500" h="25400"/>
+          </a:sp3d>
+        </a:effectStyle>
+      </a:effectStyleLst>
+      <a:bgFillStyleLst>
+        <a:solidFill>
+          <a:schemeClr val="phClr"/>
+        </a:solidFill>
+        <a:gradFill rotWithShape="1">
+          <a:gsLst>
+            <a:gs pos="0">
+              <a:schemeClr val="phClr">
+                <a:tint val="40000"/>
+                <a:satMod val="350000"/>
+              </a:schemeClr>
+            </a:gs>
+            <a:gs pos="40000">
+              <a:schemeClr val="phClr">
+                <a:tint val="45000"/>
+                <a:shade val="99000"/>
+                <a:satMod val="350000"/>
+              </a:schemeClr>
+            </a:gs>
+            <a:gs pos="100000">
+              <a:schemeClr val="phClr">
+                <a:shade val="20000"/>
+                <a:satMod val="255000"/>
+              </a:schemeClr>
+            </a:gs>
+          </a:gsLst>
+          <a:path path="circle">
+            <a:fillToRect l="50000" t="-80000" r="50000" b="180000"/>
+          </a:path>
+        </a:gradFill>
+        <a:gradFill rotWithShape="1">
+          <a:gsLst>
+            <a:gs pos="0">
+              <a:schemeClr val="phClr">
+                <a:tint val="80000"/>
+                <a:satMod val="300000"/>
+              </a:schemeClr>
+            </a:gs>
+            <a:gs pos="100000">
+              <a:schemeClr val="phClr">
+                <a:shade val="30000"/>
+                <a:satMod val="200000"/>
+              </a:schemeClr>
+            </a:gs>
+          </a:gsLst>
+          <a:path path="circle">
+            <a:fillToRect l="50000" t="50000" r="50000" b="50000"/>
+          </a:path>
+        </a:gradFill>
+      </a:bgFillStyleLst>
+    </a:fmtScheme>
+  </a:themeElements>
+  <a:objectDefaults>
+    <a:spDef>
+      <a:spPr/>
+      <a:bodyPr/>
+      <a:lstStyle/>
+      <a:style>
+        <a:lnRef idx="1">
+          <a:schemeClr val="accent1"/>
+        </a:lnRef>
+        <a:fillRef idx="3">
+          <a:schemeClr val="accent1"/>
+        </a:fillRef>
+        <a:effectRef idx="2">
+          <a:schemeClr val="accent1"/>
+        </a:effectRef>
+        <a:fontRef idx="minor">
+          <a:schemeClr val="lt1"/>
+        </a:fontRef>
+      </a:style>
+    </a:spDef>
+    <a:lnDef>
+      <a:spPr/>
+      <a:bodyPr/>
+      <a:lstStyle/>
+      <a:style>
+        <a:lnRef idx="2">
+          <a:schemeClr val="accent1"/>
+        </a:lnRef>
+        <a:fillRef idx="0">
+          <a:schemeClr val="accent1"/>
+        </a:fillRef>
+        <a:effectRef idx="1">
+          <a:schemeClr val="accent1"/>
+        </a:effectRef>
+        <a:fontRef idx="minor">
+          <a:schemeClr val="tx1"/>
+        </a:fontRef>
+      </a:style>
+    </a:lnDef>
+  </a:objectDefaults>
+  <a:extraClrSchemeLst/>
+</a:theme>
 </file>
</xml_diff>

<commit_message>
deck: comparison-table slide restored after agent restyle
</commit_message>
<xml_diff>
--- a/data/delphi_technical.pptx
+++ b/data/delphi_technical.pptx
@@ -12,7 +12,8 @@
     <p:sldId id="260" r:id="rId11"/>
     <p:sldId id="261" r:id="rId12"/>
     <p:sldId id="262" r:id="rId13"/>
-    <p:sldId id="263" r:id="rId14"/>
+    <p:sldId id="263" r:id="rId15"/>
+    <p:sldId id="264" r:id="rId16"/>
   </p:sldIdLst>
   <p:sldSz cx="12191695" cy="6858000" type="screen4x3"/>
   <p:notesSz cx="6858000" cy="9144000"/>
@@ -465,6 +466,76 @@
 </file>
 
 <file path=ppt/notesSlides/notesSlide1.xml><?xml version="1.0" encoding="utf-8"?>
+<p:notes xmlns:a="http://schemas.openxmlformats.org/drawingml/2006/main" xmlns:p="http://schemas.openxmlformats.org/presentationml/2006/main" xmlns:r="http://schemas.openxmlformats.org/officeDocument/2006/relationships">
+  <p:cSld>
+    <p:spTree>
+      <p:nvGrpSpPr>
+        <p:cNvPr id="1" name=""/>
+        <p:cNvGrpSpPr/>
+        <p:nvPr/>
+      </p:nvGrpSpPr>
+      <p:grpSpPr>
+        <a:xfrm>
+          <a:off x="0" y="0"/>
+          <a:ext cx="0" cy="0"/>
+          <a:chOff x="0" y="0"/>
+          <a:chExt cx="0" cy="0"/>
+        </a:xfrm>
+      </p:grpSpPr>
+      <p:sp>
+        <p:nvSpPr>
+          <p:cNvPr id="2" name="Slide Image Placeholder 1"/>
+          <p:cNvSpPr>
+            <a:spLocks noGrp="1"/>
+          </p:cNvSpPr>
+          <p:nvPr>
+            <p:ph type="sldImg" idx="2"/>
+          </p:nvPr>
+        </p:nvSpPr>
+        <p:spPr/>
+      </p:sp>
+      <p:sp>
+        <p:nvSpPr>
+          <p:cNvPr id="3" name="Notes Placeholder 2"/>
+          <p:cNvSpPr>
+            <a:spLocks noGrp="1"/>
+          </p:cNvSpPr>
+          <p:nvPr>
+            <p:ph type="body" idx="3" sz="quarter"/>
+          </p:nvPr>
+        </p:nvSpPr>
+        <p:spPr/>
+        <p:txBody>
+          <a:bodyPr/>
+          <a:lstStyle/>
+          <a:p>
+            <a:r>
+              <a:t>The stack: Fact-Check &gt; Marty (FINAL) &gt; DelphiCursor &gt; Delphi3080 &gt; Panel &gt; Swarm.</a:t>
+            </a:r>
+          </a:p>
+        </p:txBody>
+      </p:sp>
+      <p:sp>
+        <p:nvSpPr>
+          <p:cNvPr id="4" name="Slide Number Placeholder 3"/>
+          <p:cNvSpPr>
+            <a:spLocks noGrp="1"/>
+          </p:cNvSpPr>
+          <p:nvPr>
+            <p:ph type="sldNum" idx="5" sz="quarter"/>
+          </p:nvPr>
+        </p:nvSpPr>
+        <p:spPr/>
+      </p:sp>
+    </p:spTree>
+  </p:cSld>
+  <p:clrMapOvr>
+    <a:masterClrMapping/>
+  </p:clrMapOvr>
+</p:notes>
+</file>
+
+<file path=ppt/notesSlides/notesSlide2.xml><?xml version="1.0" encoding="utf-8"?>
 <p:notes xmlns:a="http://schemas.openxmlformats.org/drawingml/2006/main" xmlns:p="http://schemas.openxmlformats.org/presentationml/2006/main" xmlns:r="http://schemas.openxmlformats.org/officeDocument/2006/relationships">
   <p:cSld>
     <p:spTree>
@@ -3567,6 +3638,29 @@
       </p:sp>
       <p:sp>
         <p:nvSpPr>
+          <p:cNvPr id="6" name="Slide Number Placeholder 5"/>
+          <p:cNvSpPr>
+            <a:spLocks noGrp="1"/>
+          </p:cNvSpPr>
+          <p:nvPr>
+            <p:ph type="sldNum" sz="quarter" idx="12"/>
+          </p:nvPr>
+        </p:nvSpPr>
+        <p:spPr/>
+        <p:txBody>
+          <a:bodyPr/>
+          <a:lstStyle/>
+          <a:p>
+            <a:fld id="{C1FF6DA9-008F-8B48-92A6-B652298478BF}" type="slidenum">
+              <a:rPr lang="en-US" smtClean="0"/>
+              <a:t>‹#›</a:t>
+            </a:fld>
+            <a:endParaRPr lang="en-US"/>
+          </a:p>
+        </p:txBody>
+      </p:sp>
+      <p:sp>
+        <p:nvSpPr>
           <p:cNvPr id="5" name="Footer Placeholder 4"/>
           <p:cNvSpPr>
             <a:spLocks noGrp="1"/>
@@ -3581,8 +3675,88 @@
           <a:lstStyle/>
           <a:p>
             <a:r>
-              <a:t>SeerScore.AI · adjudication internals · v1</a:t>
-            </a:r>
+              <a:t>SeerScore.AI</a:t>
+            </a:r>
+          </a:p>
+        </p:txBody>
+      </p:sp>
+      <p:sp>
+        <p:nvSpPr>
+          <p:cNvPr id="7" name="Rectangle 6"/>
+          <p:cNvSpPr/>
+          <p:nvPr/>
+        </p:nvSpPr>
+        <p:spPr>
+          <a:xfrm>
+            <a:off x="0" y="0"/>
+            <a:ext cx="109728" cy="6858000"/>
+          </a:xfrm>
+          <a:prstGeom prst="rect">
+            <a:avLst/>
+          </a:prstGeom>
+          <a:solidFill>
+            <a:srgbClr val="F59E0B"/>
+          </a:solidFill>
+        </p:spPr>
+        <p:style>
+          <a:lnRef idx="1">
+            <a:schemeClr val="accent1"/>
+          </a:lnRef>
+          <a:fillRef idx="3">
+            <a:schemeClr val="accent1"/>
+          </a:fillRef>
+          <a:effectRef idx="2">
+            <a:schemeClr val="accent1"/>
+          </a:effectRef>
+          <a:fontRef idx="minor">
+            <a:schemeClr val="lt1"/>
+          </a:fontRef>
+        </p:style>
+        <p:txBody>
+          <a:bodyPr rtlCol="0" anchor="ctr"/>
+          <a:lstStyle/>
+          <a:p>
+            <a:pPr algn="ctr"/>
+          </a:p>
+        </p:txBody>
+      </p:sp>
+      <p:sp>
+        <p:nvSpPr>
+          <p:cNvPr id="8" name="Rectangle 7"/>
+          <p:cNvSpPr/>
+          <p:nvPr/>
+        </p:nvSpPr>
+        <p:spPr>
+          <a:xfrm>
+            <a:off x="1371600" y="4114800"/>
+            <a:ext cx="3657600" cy="13716"/>
+          </a:xfrm>
+          <a:prstGeom prst="rect">
+            <a:avLst/>
+          </a:prstGeom>
+          <a:solidFill>
+            <a:srgbClr val="7DD3FC"/>
+          </a:solidFill>
+        </p:spPr>
+        <p:style>
+          <a:lnRef idx="1">
+            <a:schemeClr val="accent1"/>
+          </a:lnRef>
+          <a:fillRef idx="3">
+            <a:schemeClr val="accent1"/>
+          </a:fillRef>
+          <a:effectRef idx="2">
+            <a:schemeClr val="accent1"/>
+          </a:effectRef>
+          <a:fontRef idx="minor">
+            <a:schemeClr val="lt1"/>
+          </a:fontRef>
+        </p:style>
+        <p:txBody>
+          <a:bodyPr rtlCol="0" anchor="ctr"/>
+          <a:lstStyle/>
+          <a:p>
+            <a:pPr algn="ctr"/>
           </a:p>
         </p:txBody>
       </p:sp>
@@ -3684,6 +3858,90 @@
           </a:p>
         </p:txBody>
       </p:sp>
+      <p:sp>
+        <p:nvSpPr>
+          <p:cNvPr id="6" name="Slide Number Placeholder 5"/>
+          <p:cNvSpPr>
+            <a:spLocks noGrp="1"/>
+          </p:cNvSpPr>
+          <p:nvPr>
+            <p:ph type="sldNum" sz="quarter" idx="12"/>
+          </p:nvPr>
+        </p:nvSpPr>
+        <p:spPr/>
+        <p:txBody>
+          <a:bodyPr/>
+          <a:lstStyle/>
+          <a:p>
+            <a:fld id="{C1FF6DA9-008F-8B48-92A6-B652298478BF}" type="slidenum">
+              <a:rPr lang="en-US" smtClean="0"/>
+              <a:t>‹#›</a:t>
+            </a:fld>
+            <a:endParaRPr lang="en-US"/>
+          </a:p>
+        </p:txBody>
+      </p:sp>
+      <p:sp>
+        <p:nvSpPr>
+          <p:cNvPr id="5" name="Footer Placeholder 4"/>
+          <p:cNvSpPr>
+            <a:spLocks noGrp="1"/>
+          </p:cNvSpPr>
+          <p:nvPr>
+            <p:ph type="ftr" sz="quarter" idx="11"/>
+          </p:nvPr>
+        </p:nvSpPr>
+        <p:spPr/>
+        <p:txBody>
+          <a:bodyPr/>
+          <a:lstStyle/>
+          <a:p>
+            <a:r>
+              <a:t>SeerScore.AI</a:t>
+            </a:r>
+          </a:p>
+        </p:txBody>
+      </p:sp>
+      <p:sp>
+        <p:nvSpPr>
+          <p:cNvPr id="7" name="Rectangle 6"/>
+          <p:cNvSpPr/>
+          <p:nvPr/>
+        </p:nvSpPr>
+        <p:spPr>
+          <a:xfrm>
+            <a:off x="0" y="0"/>
+            <a:ext cx="73152" cy="6858000"/>
+          </a:xfrm>
+          <a:prstGeom prst="rect">
+            <a:avLst/>
+          </a:prstGeom>
+          <a:solidFill>
+            <a:srgbClr val="F59E0B"/>
+          </a:solidFill>
+        </p:spPr>
+        <p:style>
+          <a:lnRef idx="1">
+            <a:schemeClr val="accent1"/>
+          </a:lnRef>
+          <a:fillRef idx="3">
+            <a:schemeClr val="accent1"/>
+          </a:fillRef>
+          <a:effectRef idx="2">
+            <a:schemeClr val="accent1"/>
+          </a:effectRef>
+          <a:fontRef idx="minor">
+            <a:schemeClr val="lt1"/>
+          </a:fontRef>
+        </p:style>
+        <p:txBody>
+          <a:bodyPr rtlCol="0" anchor="ctr"/>
+          <a:lstStyle/>
+          <a:p>
+            <a:pPr algn="ctr"/>
+          </a:p>
+        </p:txBody>
+      </p:sp>
     </p:spTree>
   </p:cSld>
   <p:clrMapOvr>
@@ -3782,6 +4040,90 @@
           </a:p>
         </p:txBody>
       </p:sp>
+      <p:sp>
+        <p:nvSpPr>
+          <p:cNvPr id="6" name="Slide Number Placeholder 5"/>
+          <p:cNvSpPr>
+            <a:spLocks noGrp="1"/>
+          </p:cNvSpPr>
+          <p:nvPr>
+            <p:ph type="sldNum" sz="quarter" idx="12"/>
+          </p:nvPr>
+        </p:nvSpPr>
+        <p:spPr/>
+        <p:txBody>
+          <a:bodyPr/>
+          <a:lstStyle/>
+          <a:p>
+            <a:fld id="{C1FF6DA9-008F-8B48-92A6-B652298478BF}" type="slidenum">
+              <a:rPr lang="en-US" smtClean="0"/>
+              <a:t>‹#›</a:t>
+            </a:fld>
+            <a:endParaRPr lang="en-US"/>
+          </a:p>
+        </p:txBody>
+      </p:sp>
+      <p:sp>
+        <p:nvSpPr>
+          <p:cNvPr id="5" name="Footer Placeholder 4"/>
+          <p:cNvSpPr>
+            <a:spLocks noGrp="1"/>
+          </p:cNvSpPr>
+          <p:nvPr>
+            <p:ph type="ftr" sz="quarter" idx="11"/>
+          </p:nvPr>
+        </p:nvSpPr>
+        <p:spPr/>
+        <p:txBody>
+          <a:bodyPr/>
+          <a:lstStyle/>
+          <a:p>
+            <a:r>
+              <a:t>SeerScore.AI</a:t>
+            </a:r>
+          </a:p>
+        </p:txBody>
+      </p:sp>
+      <p:sp>
+        <p:nvSpPr>
+          <p:cNvPr id="7" name="Rectangle 6"/>
+          <p:cNvSpPr/>
+          <p:nvPr/>
+        </p:nvSpPr>
+        <p:spPr>
+          <a:xfrm>
+            <a:off x="0" y="0"/>
+            <a:ext cx="73152" cy="6858000"/>
+          </a:xfrm>
+          <a:prstGeom prst="rect">
+            <a:avLst/>
+          </a:prstGeom>
+          <a:solidFill>
+            <a:srgbClr val="22C55E"/>
+          </a:solidFill>
+        </p:spPr>
+        <p:style>
+          <a:lnRef idx="1">
+            <a:schemeClr val="accent1"/>
+          </a:lnRef>
+          <a:fillRef idx="3">
+            <a:schemeClr val="accent1"/>
+          </a:fillRef>
+          <a:effectRef idx="2">
+            <a:schemeClr val="accent1"/>
+          </a:effectRef>
+          <a:fontRef idx="minor">
+            <a:schemeClr val="lt1"/>
+          </a:fontRef>
+        </p:style>
+        <p:txBody>
+          <a:bodyPr rtlCol="0" anchor="ctr"/>
+          <a:lstStyle/>
+          <a:p>
+            <a:pPr algn="ctr"/>
+          </a:p>
+        </p:txBody>
+      </p:sp>
     </p:spTree>
   </p:cSld>
   <p:clrMapOvr>
@@ -3880,6 +4222,90 @@
           </a:p>
         </p:txBody>
       </p:sp>
+      <p:sp>
+        <p:nvSpPr>
+          <p:cNvPr id="6" name="Slide Number Placeholder 5"/>
+          <p:cNvSpPr>
+            <a:spLocks noGrp="1"/>
+          </p:cNvSpPr>
+          <p:nvPr>
+            <p:ph type="sldNum" sz="quarter" idx="12"/>
+          </p:nvPr>
+        </p:nvSpPr>
+        <p:spPr/>
+        <p:txBody>
+          <a:bodyPr/>
+          <a:lstStyle/>
+          <a:p>
+            <a:fld id="{C1FF6DA9-008F-8B48-92A6-B652298478BF}" type="slidenum">
+              <a:rPr lang="en-US" smtClean="0"/>
+              <a:t>‹#›</a:t>
+            </a:fld>
+            <a:endParaRPr lang="en-US"/>
+          </a:p>
+        </p:txBody>
+      </p:sp>
+      <p:sp>
+        <p:nvSpPr>
+          <p:cNvPr id="5" name="Footer Placeholder 4"/>
+          <p:cNvSpPr>
+            <a:spLocks noGrp="1"/>
+          </p:cNvSpPr>
+          <p:nvPr>
+            <p:ph type="ftr" sz="quarter" idx="11"/>
+          </p:nvPr>
+        </p:nvSpPr>
+        <p:spPr/>
+        <p:txBody>
+          <a:bodyPr/>
+          <a:lstStyle/>
+          <a:p>
+            <a:r>
+              <a:t>SeerScore.AI</a:t>
+            </a:r>
+          </a:p>
+        </p:txBody>
+      </p:sp>
+      <p:sp>
+        <p:nvSpPr>
+          <p:cNvPr id="7" name="Rectangle 6"/>
+          <p:cNvSpPr/>
+          <p:nvPr/>
+        </p:nvSpPr>
+        <p:spPr>
+          <a:xfrm>
+            <a:off x="0" y="0"/>
+            <a:ext cx="73152" cy="6858000"/>
+          </a:xfrm>
+          <a:prstGeom prst="rect">
+            <a:avLst/>
+          </a:prstGeom>
+          <a:solidFill>
+            <a:srgbClr val="7DD3FC"/>
+          </a:solidFill>
+        </p:spPr>
+        <p:style>
+          <a:lnRef idx="1">
+            <a:schemeClr val="accent1"/>
+          </a:lnRef>
+          <a:fillRef idx="3">
+            <a:schemeClr val="accent1"/>
+          </a:fillRef>
+          <a:effectRef idx="2">
+            <a:schemeClr val="accent1"/>
+          </a:effectRef>
+          <a:fontRef idx="minor">
+            <a:schemeClr val="lt1"/>
+          </a:fontRef>
+        </p:style>
+        <p:txBody>
+          <a:bodyPr rtlCol="0" anchor="ctr"/>
+          <a:lstStyle/>
+          <a:p>
+            <a:pPr algn="ctr"/>
+          </a:p>
+        </p:txBody>
+      </p:sp>
     </p:spTree>
   </p:cSld>
   <p:clrMapOvr>
@@ -3978,6 +4404,90 @@
           </a:p>
         </p:txBody>
       </p:sp>
+      <p:sp>
+        <p:nvSpPr>
+          <p:cNvPr id="6" name="Slide Number Placeholder 5"/>
+          <p:cNvSpPr>
+            <a:spLocks noGrp="1"/>
+          </p:cNvSpPr>
+          <p:nvPr>
+            <p:ph type="sldNum" sz="quarter" idx="12"/>
+          </p:nvPr>
+        </p:nvSpPr>
+        <p:spPr/>
+        <p:txBody>
+          <a:bodyPr/>
+          <a:lstStyle/>
+          <a:p>
+            <a:fld id="{C1FF6DA9-008F-8B48-92A6-B652298478BF}" type="slidenum">
+              <a:rPr lang="en-US" smtClean="0"/>
+              <a:t>‹#›</a:t>
+            </a:fld>
+            <a:endParaRPr lang="en-US"/>
+          </a:p>
+        </p:txBody>
+      </p:sp>
+      <p:sp>
+        <p:nvSpPr>
+          <p:cNvPr id="5" name="Footer Placeholder 4"/>
+          <p:cNvSpPr>
+            <a:spLocks noGrp="1"/>
+          </p:cNvSpPr>
+          <p:nvPr>
+            <p:ph type="ftr" sz="quarter" idx="11"/>
+          </p:nvPr>
+        </p:nvSpPr>
+        <p:spPr/>
+        <p:txBody>
+          <a:bodyPr/>
+          <a:lstStyle/>
+          <a:p>
+            <a:r>
+              <a:t>SeerScore.AI</a:t>
+            </a:r>
+          </a:p>
+        </p:txBody>
+      </p:sp>
+      <p:sp>
+        <p:nvSpPr>
+          <p:cNvPr id="7" name="Rectangle 6"/>
+          <p:cNvSpPr/>
+          <p:nvPr/>
+        </p:nvSpPr>
+        <p:spPr>
+          <a:xfrm>
+            <a:off x="0" y="0"/>
+            <a:ext cx="73152" cy="6858000"/>
+          </a:xfrm>
+          <a:prstGeom prst="rect">
+            <a:avLst/>
+          </a:prstGeom>
+          <a:solidFill>
+            <a:srgbClr val="F59E0B"/>
+          </a:solidFill>
+        </p:spPr>
+        <p:style>
+          <a:lnRef idx="1">
+            <a:schemeClr val="accent1"/>
+          </a:lnRef>
+          <a:fillRef idx="3">
+            <a:schemeClr val="accent1"/>
+          </a:fillRef>
+          <a:effectRef idx="2">
+            <a:schemeClr val="accent1"/>
+          </a:effectRef>
+          <a:fontRef idx="minor">
+            <a:schemeClr val="lt1"/>
+          </a:fontRef>
+        </p:style>
+        <p:txBody>
+          <a:bodyPr rtlCol="0" anchor="ctr"/>
+          <a:lstStyle/>
+          <a:p>
+            <a:pPr algn="ctr"/>
+          </a:p>
+        </p:txBody>
+      </p:sp>
     </p:spTree>
   </p:cSld>
   <p:clrMapOvr>
@@ -4069,6 +4579,90 @@
           </a:p>
         </p:txBody>
       </p:sp>
+      <p:sp>
+        <p:nvSpPr>
+          <p:cNvPr id="6" name="Slide Number Placeholder 5"/>
+          <p:cNvSpPr>
+            <a:spLocks noGrp="1"/>
+          </p:cNvSpPr>
+          <p:nvPr>
+            <p:ph type="sldNum" sz="quarter" idx="12"/>
+          </p:nvPr>
+        </p:nvSpPr>
+        <p:spPr/>
+        <p:txBody>
+          <a:bodyPr/>
+          <a:lstStyle/>
+          <a:p>
+            <a:fld id="{C1FF6DA9-008F-8B48-92A6-B652298478BF}" type="slidenum">
+              <a:rPr lang="en-US" smtClean="0"/>
+              <a:t>‹#›</a:t>
+            </a:fld>
+            <a:endParaRPr lang="en-US"/>
+          </a:p>
+        </p:txBody>
+      </p:sp>
+      <p:sp>
+        <p:nvSpPr>
+          <p:cNvPr id="5" name="Footer Placeholder 4"/>
+          <p:cNvSpPr>
+            <a:spLocks noGrp="1"/>
+          </p:cNvSpPr>
+          <p:nvPr>
+            <p:ph type="ftr" sz="quarter" idx="11"/>
+          </p:nvPr>
+        </p:nvSpPr>
+        <p:spPr/>
+        <p:txBody>
+          <a:bodyPr/>
+          <a:lstStyle/>
+          <a:p>
+            <a:r>
+              <a:t>SeerScore.AI</a:t>
+            </a:r>
+          </a:p>
+        </p:txBody>
+      </p:sp>
+      <p:sp>
+        <p:nvSpPr>
+          <p:cNvPr id="7" name="Rectangle 6"/>
+          <p:cNvSpPr/>
+          <p:nvPr/>
+        </p:nvSpPr>
+        <p:spPr>
+          <a:xfrm>
+            <a:off x="0" y="0"/>
+            <a:ext cx="73152" cy="6858000"/>
+          </a:xfrm>
+          <a:prstGeom prst="rect">
+            <a:avLst/>
+          </a:prstGeom>
+          <a:solidFill>
+            <a:srgbClr val="22C55E"/>
+          </a:solidFill>
+        </p:spPr>
+        <p:style>
+          <a:lnRef idx="1">
+            <a:schemeClr val="accent1"/>
+          </a:lnRef>
+          <a:fillRef idx="3">
+            <a:schemeClr val="accent1"/>
+          </a:fillRef>
+          <a:effectRef idx="2">
+            <a:schemeClr val="accent1"/>
+          </a:effectRef>
+          <a:fontRef idx="minor">
+            <a:schemeClr val="lt1"/>
+          </a:fontRef>
+        </p:style>
+        <p:txBody>
+          <a:bodyPr rtlCol="0" anchor="ctr"/>
+          <a:lstStyle/>
+          <a:p>
+            <a:pPr algn="ctr"/>
+          </a:p>
+        </p:txBody>
+      </p:sp>
     </p:spTree>
   </p:cSld>
   <p:clrMapOvr>
@@ -4111,7 +4705,7 @@
           <a:lstStyle/>
           <a:p>
             <a:r>
-              <a:t>6 · Known technical gaps</a:t>
+              <a:t>Differences vs the MiroFish public service</a:t>
             </a:r>
           </a:p>
         </p:txBody>
@@ -4130,36 +4724,387 @@
         <p:txBody>
           <a:bodyPr/>
           <a:lstStyle/>
-          <a:p>
-            <a:pPr/>
-            <a:r>
-              <a:rPr/>
-              <a:t>Zero-entity extraction runs → empty graph → degraded rounds (root cause: strict own-voice prompt vs LLM extraction ability); needs extraction-robustness scoring</a:t>
-            </a:r>
-          </a:p>
-          <a:p>
-            <a:pPr/>
-            <a:r>
-              <a:rPr/>
-              <a:t>ReportAgent confidence is uncalibrated (no Brier/log-score tracking yet); swarm gives us the labeled distribution to calibrate against</a:t>
-            </a:r>
-          </a:p>
-          <a:p>
-            <a:pPr/>
-            <a:r>
-              <a:rPr/>
-              <a:t>Round depth (2) chosen for latency, not validated for evidence saturation — MiroFish's deeper rounds may matter on multi-entity claims</a:t>
-            </a:r>
-          </a:p>
-          <a:p>
-            <a:pPr/>
-            <a:r>
-              <a:rPr/>
-              <a:t>Single-judge DelphiCursor is non-deterministic; determinism is procedural (schema, timeout, isolation), not statistical — k-sample voting is the documented fallback</a:t>
-            </a:r>
-          </a:p>
-        </p:txBody>
-      </p:sp>
+          <a:p/>
+        </p:txBody>
+      </p:sp>
+      <p:graphicFrame>
+        <p:nvGraphicFramePr>
+          <p:cNvPr id="4" name="Table 3"/>
+          <p:cNvGraphicFramePr>
+            <a:graphicFrameLocks noGrp="1"/>
+          </p:cNvGraphicFramePr>
+          <p:nvPr/>
+        </p:nvGraphicFramePr>
+        <p:xfrm>
+          <a:off x="365760" y="1280160"/>
+          <a:ext cx="11247120" cy="4206240"/>
+        </p:xfrm>
+        <a:graphic>
+          <a:graphicData uri="http://schemas.openxmlformats.org/drawingml/2006/table">
+            <a:tbl>
+              <a:tblPr firstRow="1" bandRow="1">
+                <a:tableStyleId>{5C22544A-7EE6-4342-B048-85BDC9FD1C3A}</a:tableStyleId>
+              </a:tblPr>
+              <a:tblGrid>
+                <a:gridCol w="2811780"/>
+                <a:gridCol w="2811780"/>
+                <a:gridCol w="2811780"/>
+                <a:gridCol w="2811780"/>
+              </a:tblGrid>
+              <a:tr h="600891">
+                <a:tc>
+                  <a:txBody>
+                    <a:bodyPr/>
+                    <a:lstStyle/>
+                    <a:p>
+                      <a:r>
+                        <a:t>Dimension</a:t>
+                      </a:r>
+                    </a:p>
+                  </a:txBody>
+                  <a:tcPr/>
+                </a:tc>
+                <a:tc>
+                  <a:txBody>
+                    <a:bodyPr/>
+                    <a:lstStyle/>
+                    <a:p>
+                      <a:r>
+                        <a:t>MiroFish public service</a:t>
+                      </a:r>
+                    </a:p>
+                  </a:txBody>
+                  <a:tcPr/>
+                </a:tc>
+                <a:tc>
+                  <a:txBody>
+                    <a:bodyPr/>
+                    <a:lstStyle/>
+                    <a:p>
+                      <a:r>
+                        <a:t>Delphi3080 (ours)</a:t>
+                      </a:r>
+                    </a:p>
+                  </a:txBody>
+                  <a:tcPr/>
+                </a:tc>
+                <a:tc>
+                  <a:txBody>
+                    <a:bodyPr/>
+                    <a:lstStyle/>
+                    <a:p>
+                      <a:r>
+                        <a:t>DelphiCursor (ours)</a:t>
+                      </a:r>
+                    </a:p>
+                  </a:txBody>
+                  <a:tcPr/>
+                </a:tc>
+              </a:tr>
+              <a:tr h="600891">
+                <a:tc>
+                  <a:txBody>
+                    <a:bodyPr/>
+                    <a:lstStyle/>
+                    <a:p>
+                      <a:r>
+                        <a:t>Judge</a:t>
+                      </a:r>
+                    </a:p>
+                  </a:txBody>
+                  <a:tcPr/>
+                </a:tc>
+                <a:tc>
+                  <a:txBody>
+                    <a:bodyPr/>
+                    <a:lstStyle/>
+                    <a:p>
+                      <a:r>
+                        <a:t>Multiple role agents, generic</a:t>
+                      </a:r>
+                    </a:p>
+                  </a:txBody>
+                  <a:tcPr/>
+                </a:tc>
+                <a:tc>
+                  <a:txBody>
+                    <a:bodyPr/>
+                    <a:lstStyle/>
+                    <a:p>
+                      <a:r>
+                        <a:t>Simulated specialists, 32B local</a:t>
+                      </a:r>
+                    </a:p>
+                  </a:txBody>
+                  <a:tcPr/>
+                </a:tc>
+                <a:tc>
+                  <a:txBody>
+                    <a:bodyPr/>
+                    <a:lstStyle/>
+                    <a:p>
+                      <a:r>
+                        <a:t>Single Opus-class, may browse</a:t>
+                      </a:r>
+                    </a:p>
+                  </a:txBody>
+                  <a:tcPr/>
+                </a:tc>
+              </a:tr>
+              <a:tr h="600891">
+                <a:tc>
+                  <a:txBody>
+                    <a:bodyPr/>
+                    <a:lstStyle/>
+                    <a:p>
+                      <a:r>
+                        <a:t>Knowledge graph</a:t>
+                      </a:r>
+                    </a:p>
+                  </a:txBody>
+                  <a:tcPr/>
+                </a:tc>
+                <a:tc>
+                  <a:txBody>
+                    <a:bodyPr/>
+                    <a:lstStyle/>
+                    <a:p>
+                      <a:r>
+                        <a:t>Core deliverable</a:t>
+                      </a:r>
+                    </a:p>
+                  </a:txBody>
+                  <a:tcPr/>
+                </a:tc>
+                <a:tc>
+                  <a:txBody>
+                    <a:bodyPr/>
+                    <a:lstStyle/>
+                    <a:p>
+                      <a:r>
+                        <a:t>Reused (Graphiti/Neo4j)</a:t>
+                      </a:r>
+                    </a:p>
+                  </a:txBody>
+                  <a:tcPr/>
+                </a:tc>
+                <a:tc>
+                  <a:txBody>
+                    <a:bodyPr/>
+                    <a:lstStyle/>
+                    <a:p>
+                      <a:r>
+                        <a:t>None - fixture-only</a:t>
+                      </a:r>
+                    </a:p>
+                  </a:txBody>
+                  <a:tcPr/>
+                </a:tc>
+              </a:tr>
+              <a:tr h="600891">
+                <a:tc>
+                  <a:txBody>
+                    <a:bodyPr/>
+                    <a:lstStyle/>
+                    <a:p>
+                      <a:r>
+                        <a:t>Latency / claim</a:t>
+                      </a:r>
+                    </a:p>
+                  </a:txBody>
+                  <a:tcPr/>
+                </a:tc>
+                <a:tc>
+                  <a:txBody>
+                    <a:bodyPr/>
+                    <a:lstStyle/>
+                    <a:p>
+                      <a:r>
+                        <a:t>Minutes-hours, unbounded</a:t>
+                      </a:r>
+                    </a:p>
+                  </a:txBody>
+                  <a:tcPr/>
+                </a:tc>
+                <a:tc>
+                  <a:txBody>
+                    <a:bodyPr/>
+                    <a:lstStyle/>
+                    <a:p>
+                      <a:r>
+                        <a:t>~15-30 min</a:t>
+                      </a:r>
+                    </a:p>
+                  </a:txBody>
+                  <a:tcPr/>
+                </a:tc>
+                <a:tc>
+                  <a:txBody>
+                    <a:bodyPr/>
+                    <a:lstStyle/>
+                    <a:p>
+                      <a:r>
+                        <a:t>~1-5 min (timeout 300s)</a:t>
+                      </a:r>
+                    </a:p>
+                  </a:txBody>
+                  <a:tcPr/>
+                </a:tc>
+              </a:tr>
+              <a:tr h="600891">
+                <a:tc>
+                  <a:txBody>
+                    <a:bodyPr/>
+                    <a:lstStyle/>
+                    <a:p>
+                      <a:r>
+                        <a:t>Cost</a:t>
+                      </a:r>
+                    </a:p>
+                  </a:txBody>
+                  <a:tcPr/>
+                </a:tc>
+                <a:tc>
+                  <a:txBody>
+                    <a:bodyPr/>
+                    <a:lstStyle/>
+                    <a:p>
+                      <a:r>
+                        <a:t>High</a:t>
+                      </a:r>
+                    </a:p>
+                  </a:txBody>
+                  <a:tcPr/>
+                </a:tc>
+                <a:tc>
+                  <a:txBody>
+                    <a:bodyPr/>
+                    <a:lstStyle/>
+                    <a:p>
+                      <a:r>
+                        <a:t>$0 marginal</a:t>
+                      </a:r>
+                    </a:p>
+                  </a:txBody>
+                  <a:tcPr/>
+                </a:tc>
+                <a:tc>
+                  <a:txBody>
+                    <a:bodyPr/>
+                    <a:lstStyle/>
+                    <a:p>
+                      <a:r>
+                        <a:t>Paid Cursor (flat-fee)</a:t>
+                      </a:r>
+                    </a:p>
+                  </a:txBody>
+                  <a:tcPr/>
+                </a:tc>
+              </a:tr>
+              <a:tr h="600891">
+                <a:tc>
+                  <a:txBody>
+                    <a:bodyPr/>
+                    <a:lstStyle/>
+                    <a:p>
+                      <a:r>
+                        <a:t>Scale target</a:t>
+                      </a:r>
+                    </a:p>
+                  </a:txBody>
+                  <a:tcPr/>
+                </a:tc>
+                <a:tc>
+                  <a:txBody>
+                    <a:bodyPr/>
+                    <a:lstStyle/>
+                    <a:p>
+                      <a:r>
+                        <a:t>Deep research per claim</a:t>
+                      </a:r>
+                    </a:p>
+                  </a:txBody>
+                  <a:tcPr/>
+                </a:tc>
+                <a:tc>
+                  <a:txBody>
+                    <a:bodyPr/>
+                    <a:lstStyle/>
+                    <a:p>
+                      <a:r>
+                        <a:t>All graded predictions daily</a:t>
+                      </a:r>
+                    </a:p>
+                  </a:txBody>
+                  <a:tcPr/>
+                </a:tc>
+                <a:tc>
+                  <a:txBody>
+                    <a:bodyPr/>
+                    <a:lstStyle/>
+                    <a:p>
+                      <a:r>
+                        <a:t>Contested cases only (Mode A)</a:t>
+                      </a:r>
+                    </a:p>
+                  </a:txBody>
+                  <a:tcPr/>
+                </a:tc>
+              </a:tr>
+              <a:tr h="600894">
+                <a:tc>
+                  <a:txBody>
+                    <a:bodyPr/>
+                    <a:lstStyle/>
+                    <a:p>
+                      <a:r>
+                        <a:t>Failure stance</a:t>
+                      </a:r>
+                    </a:p>
+                  </a:txBody>
+                  <a:tcPr/>
+                </a:tc>
+                <a:tc>
+                  <a:txBody>
+                    <a:bodyPr/>
+                    <a:lstStyle/>
+                    <a:p>
+                      <a:r>
+                        <a:t>Run must complete</a:t>
+                      </a:r>
+                    </a:p>
+                  </a:txBody>
+                  <a:tcPr/>
+                </a:tc>
+                <a:tc>
+                  <a:txBody>
+                    <a:bodyPr/>
+                    <a:lstStyle/>
+                    <a:p>
+                      <a:r>
+                        <a:t>Error-marked, queue survives</a:t>
+                      </a:r>
+                    </a:p>
+                  </a:txBody>
+                  <a:tcPr/>
+                </a:tc>
+                <a:tc>
+                  <a:txBody>
+                    <a:bodyPr/>
+                    <a:lstStyle/>
+                    <a:p>
+                      <a:r>
+                        <a:t>Validated + retry &lt;=2, capped</a:t>
+                      </a:r>
+                    </a:p>
+                  </a:txBody>
+                  <a:tcPr/>
+                </a:tc>
+              </a:tr>
+            </a:tbl>
+          </a:graphicData>
+        </a:graphic>
+      </p:graphicFrame>
     </p:spTree>
   </p:cSld>
   <p:clrMapOvr>
@@ -4202,14 +5147,233 @@
           <a:lstStyle/>
           <a:p>
             <a:r>
+              <a:t>6 · Known technical gaps</a:t>
+            </a:r>
+          </a:p>
+        </p:txBody>
+      </p:sp>
+      <p:sp>
+        <p:nvSpPr>
+          <p:cNvPr id="3" name="Content Placeholder 2"/>
+          <p:cNvSpPr>
+            <a:spLocks noGrp="1"/>
+          </p:cNvSpPr>
+          <p:nvPr>
+            <p:ph idx="1"/>
+          </p:nvPr>
+        </p:nvSpPr>
+        <p:spPr/>
+        <p:txBody>
+          <a:bodyPr/>
+          <a:lstStyle/>
+          <a:p>
+            <a:pPr/>
+            <a:r>
+              <a:rPr/>
+              <a:t>Zero-entity extraction runs → empty graph → degraded rounds (root cause: strict own-voice prompt vs LLM extraction ability); needs extraction-robustness scoring</a:t>
+            </a:r>
+          </a:p>
+          <a:p>
+            <a:pPr/>
+            <a:r>
+              <a:rPr/>
+              <a:t>ReportAgent confidence is uncalibrated (no Brier/log-score tracking yet); swarm gives us the labeled distribution to calibrate against</a:t>
+            </a:r>
+          </a:p>
+          <a:p>
+            <a:pPr/>
+            <a:r>
+              <a:rPr/>
+              <a:t>Round depth (2) chosen for latency, not validated for evidence saturation — MiroFish's deeper rounds may matter on multi-entity claims</a:t>
+            </a:r>
+          </a:p>
+          <a:p>
+            <a:pPr/>
+            <a:r>
+              <a:rPr/>
+              <a:t>Single-judge DelphiCursor is non-deterministic; determinism is procedural (schema, timeout, isolation), not statistical — k-sample voting is the documented fallback</a:t>
+            </a:r>
+          </a:p>
+        </p:txBody>
+      </p:sp>
+      <p:sp>
+        <p:nvSpPr>
+          <p:cNvPr id="6" name="Slide Number Placeholder 5"/>
+          <p:cNvSpPr>
+            <a:spLocks noGrp="1"/>
+          </p:cNvSpPr>
+          <p:nvPr>
+            <p:ph type="sldNum" sz="quarter" idx="12"/>
+          </p:nvPr>
+        </p:nvSpPr>
+        <p:spPr/>
+        <p:txBody>
+          <a:bodyPr/>
+          <a:lstStyle/>
+          <a:p>
+            <a:fld id="{C1FF6DA9-008F-8B48-92A6-B652298478BF}" type="slidenum">
+              <a:rPr lang="en-US" smtClean="0"/>
+              <a:t>‹#›</a:t>
+            </a:fld>
+            <a:endParaRPr lang="en-US"/>
+          </a:p>
+        </p:txBody>
+      </p:sp>
+      <p:sp>
+        <p:nvSpPr>
+          <p:cNvPr id="5" name="Footer Placeholder 4"/>
+          <p:cNvSpPr>
+            <a:spLocks noGrp="1"/>
+          </p:cNvSpPr>
+          <p:nvPr>
+            <p:ph type="ftr" sz="quarter" idx="11"/>
+          </p:nvPr>
+        </p:nvSpPr>
+        <p:spPr/>
+        <p:txBody>
+          <a:bodyPr/>
+          <a:lstStyle/>
+          <a:p>
+            <a:r>
+              <a:t>SeerScore.AI</a:t>
+            </a:r>
+          </a:p>
+        </p:txBody>
+      </p:sp>
+      <p:sp>
+        <p:nvSpPr>
+          <p:cNvPr id="7" name="Rectangle 6"/>
+          <p:cNvSpPr/>
+          <p:nvPr/>
+        </p:nvSpPr>
+        <p:spPr>
+          <a:xfrm>
+            <a:off x="0" y="0"/>
+            <a:ext cx="73152" cy="6858000"/>
+          </a:xfrm>
+          <a:prstGeom prst="rect">
+            <a:avLst/>
+          </a:prstGeom>
+          <a:solidFill>
+            <a:srgbClr val="7DD3FC"/>
+          </a:solidFill>
+        </p:spPr>
+        <p:style>
+          <a:lnRef idx="1">
+            <a:schemeClr val="accent1"/>
+          </a:lnRef>
+          <a:fillRef idx="3">
+            <a:schemeClr val="accent1"/>
+          </a:fillRef>
+          <a:effectRef idx="2">
+            <a:schemeClr val="accent1"/>
+          </a:effectRef>
+          <a:fontRef idx="minor">
+            <a:schemeClr val="lt1"/>
+          </a:fontRef>
+        </p:style>
+        <p:txBody>
+          <a:bodyPr rtlCol="0" anchor="ctr"/>
+          <a:lstStyle/>
+          <a:p>
+            <a:pPr algn="ctr"/>
+          </a:p>
+        </p:txBody>
+      </p:sp>
+    </p:spTree>
+  </p:cSld>
+  <p:clrMapOvr>
+    <a:masterClrMapping/>
+  </p:clrMapOvr>
+</p:sld>
+</file>
+
+<file path=ppt/slides/slide9.xml><?xml version="1.0" encoding="utf-8"?>
+<p:sld xmlns:a="http://schemas.openxmlformats.org/drawingml/2006/main" xmlns:p="http://schemas.openxmlformats.org/presentationml/2006/main" xmlns:r="http://schemas.openxmlformats.org/officeDocument/2006/relationships">
+  <p:cSld>
+    <p:bg>
+      <p:bgPr>
+        <a:solidFill>
+          <a:srgbClr val="0B1120"/>
+        </a:solidFill>
+        <a:effectLst/>
+      </p:bgPr>
+    </p:bg>
+    <p:spTree>
+      <p:nvGrpSpPr>
+        <p:cNvPr id="1" name=""/>
+        <p:cNvGrpSpPr/>
+        <p:nvPr/>
+      </p:nvGrpSpPr>
+      <p:grpSpPr/>
+      <p:sp>
+        <p:nvSpPr>
+          <p:cNvPr id="2" name="Title 1"/>
+          <p:cNvSpPr>
+            <a:spLocks noGrp="1"/>
+          </p:cNvSpPr>
+          <p:nvPr>
+            <p:ph type="title"/>
+          </p:nvPr>
+        </p:nvSpPr>
+        <p:spPr/>
+        <p:txBody>
+          <a:bodyPr/>
+          <a:lstStyle/>
+          <a:p>
+            <a:r>
               <a:t>7 · The product this adjudication feeds</a:t>
+            </a:r>
+          </a:p>
+        </p:txBody>
+      </p:sp>
+      <p:sp>
+        <p:nvSpPr>
+          <p:cNvPr id="5" name="Slide Number Placeholder 4"/>
+          <p:cNvSpPr>
+            <a:spLocks noGrp="1"/>
+          </p:cNvSpPr>
+          <p:nvPr>
+            <p:ph type="sldNum" sz="quarter" idx="12"/>
+          </p:nvPr>
+        </p:nvSpPr>
+        <p:spPr/>
+        <p:txBody>
+          <a:bodyPr/>
+          <a:lstStyle/>
+          <a:p>
+            <a:fld id="{C1FF6DA9-008F-8B48-92A6-B652298478BF}" type="slidenum">
+              <a:rPr lang="en-US" smtClean="0"/>
+              <a:t>‹#›</a:t>
+            </a:fld>
+            <a:endParaRPr lang="en-US"/>
+          </a:p>
+        </p:txBody>
+      </p:sp>
+      <p:sp>
+        <p:nvSpPr>
+          <p:cNvPr id="4" name="Footer Placeholder 3"/>
+          <p:cNvSpPr>
+            <a:spLocks noGrp="1"/>
+          </p:cNvSpPr>
+          <p:nvPr>
+            <p:ph type="ftr" sz="quarter" idx="11"/>
+          </p:nvPr>
+        </p:nvSpPr>
+        <p:spPr/>
+        <p:txBody>
+          <a:bodyPr/>
+          <a:lstStyle/>
+          <a:p>
+            <a:r>
+              <a:t>SeerScore.AI</a:t>
             </a:r>
           </a:p>
         </p:txBody>
       </p:sp>
       <p:pic>
         <p:nvPicPr>
-          <p:cNvPr id="3" name="Picture 2" descr="grid_shot.png"/>
+          <p:cNvPr id="6" name="Picture 5" descr="grid_shot.png"/>
           <p:cNvPicPr>
             <a:picLocks noChangeAspect="1"/>
           </p:cNvPicPr>
@@ -4231,6 +5395,93 @@
           </a:prstGeom>
         </p:spPr>
       </p:pic>
+      <p:sp>
+        <p:nvSpPr>
+          <p:cNvPr id="7" name="Rectangle 6"/>
+          <p:cNvSpPr/>
+          <p:nvPr/>
+        </p:nvSpPr>
+        <p:spPr>
+          <a:xfrm>
+            <a:off x="0" y="0"/>
+            <a:ext cx="73152" cy="6858000"/>
+          </a:xfrm>
+          <a:prstGeom prst="rect">
+            <a:avLst/>
+          </a:prstGeom>
+          <a:solidFill>
+            <a:srgbClr val="F59E0B"/>
+          </a:solidFill>
+        </p:spPr>
+        <p:style>
+          <a:lnRef idx="1">
+            <a:schemeClr val="accent1"/>
+          </a:lnRef>
+          <a:fillRef idx="3">
+            <a:schemeClr val="accent1"/>
+          </a:fillRef>
+          <a:effectRef idx="2">
+            <a:schemeClr val="accent1"/>
+          </a:effectRef>
+          <a:fontRef idx="minor">
+            <a:schemeClr val="lt1"/>
+          </a:fontRef>
+        </p:style>
+        <p:txBody>
+          <a:bodyPr rtlCol="0" anchor="ctr"/>
+          <a:lstStyle/>
+          <a:p>
+            <a:pPr algn="ctr"/>
+          </a:p>
+        </p:txBody>
+      </p:sp>
+      <p:sp>
+        <p:nvSpPr>
+          <p:cNvPr id="8" name="Rounded Rectangle 7"/>
+          <p:cNvSpPr/>
+          <p:nvPr/>
+        </p:nvSpPr>
+        <p:spPr>
+          <a:xfrm>
+            <a:off x="457200" y="6217920"/>
+            <a:ext cx="11430000" cy="457200"/>
+          </a:xfrm>
+          <a:prstGeom prst="roundRect">
+            <a:avLst/>
+          </a:prstGeom>
+          <a:solidFill>
+            <a:srgbClr val="1E293B"/>
+          </a:solidFill>
+        </p:spPr>
+        <p:style>
+          <a:lnRef idx="1">
+            <a:schemeClr val="accent1"/>
+          </a:lnRef>
+          <a:fillRef idx="3">
+            <a:schemeClr val="accent1"/>
+          </a:fillRef>
+          <a:effectRef idx="2">
+            <a:schemeClr val="accent1"/>
+          </a:effectRef>
+          <a:fontRef idx="minor">
+            <a:schemeClr val="lt1"/>
+          </a:fontRef>
+        </p:style>
+        <p:txBody>
+          <a:bodyPr rtlCol="0" anchor="ctr"/>
+          <a:lstStyle/>
+          <a:p>
+            <a:r>
+              <a:rPr>
+                <a:solidFill>
+                  <a:srgbClr val="94A3B8"/>
+                </a:solidFill>
+              </a:rPr>
+              <a:t>Live grid (seerscore.pages.dev) — verdict boxes, Marty final, Delphi3080 badge + hover rationale</a:t>
+            </a:r>
+          </a:p>
+        </p:txBody>
+      </p:sp>
     </p:spTree>
   </p:cSld>
   <p:clrMapOvr>

</xml_diff>